<commit_message>
Draw PPTX outer shadows and text highlight
Shapes and pictures take an outer shadow from their own effect list, their
placeholder's, or the theme effect style their style refers to, drawn as
the offset, blurred silhouette under the shape. Runs keep <a:highlight> as
a background color: white text on a highlight was invisible before.
</commit_message>
<xml_diff>
--- a/officecanvas/src/test/resources/pptx_samples/pptx_features.pptx
+++ b/officecanvas/src/test/resources/pptx_samples/pptx_features.pptx
@@ -13,6 +13,7 @@
     <p:sldId id="261" r:id="rId12"/>
     <p:sldId id="262" r:id="rId13"/>
     <p:sldId id="263" r:id="rId14"/>
+    <p:sldId id="264" r:id="rId15"/>
   </p:sldIdLst>
   <p:sldSz cx="9144000" cy="6858000" type="screen4x3"/>
   <p:notesSz cx="6858000" cy="9144000"/>
@@ -3904,6 +3905,152 @@
 </file>
 
 <file path=ppt/slides/slide8.xml><?xml version="1.0" encoding="utf-8"?>
+<p:sld xmlns:a="http://schemas.openxmlformats.org/drawingml/2006/main" xmlns:p="http://schemas.openxmlformats.org/presentationml/2006/main" xmlns:r="http://schemas.openxmlformats.org/officeDocument/2006/relationships">
+  <p:cSld>
+    <p:spTree>
+      <p:nvGrpSpPr>
+        <p:cNvPr id="1" name=""/>
+        <p:cNvGrpSpPr/>
+        <p:nvPr/>
+      </p:nvGrpSpPr>
+      <p:grpSpPr/>
+      <p:sp>
+        <p:nvSpPr>
+          <p:cNvPr id="2" name="Rectangle 1"/>
+          <p:cNvSpPr/>
+          <p:nvPr/>
+        </p:nvSpPr>
+        <p:spPr>
+          <a:xfrm>
+            <a:off x="914400" y="914400"/>
+            <a:ext cx="2743200" cy="1828800"/>
+          </a:xfrm>
+          <a:prstGeom prst="rect">
+            <a:avLst/>
+          </a:prstGeom>
+          <a:solidFill>
+            <a:srgbClr val="FFFFFF"/>
+          </a:solidFill>
+          <a:ln>
+            <a:noFill/>
+          </a:ln>
+          <a:effectLst>
+            <a:outerShdw blurRad="0" dist="152400" dir="2700000" rotWithShape="0">
+              <a:srgbClr val="000000"/>
+            </a:outerShdw>
+          </a:effectLst>
+        </p:spPr>
+        <p:style>
+          <a:lnRef idx="1">
+            <a:schemeClr val="accent1"/>
+          </a:lnRef>
+          <a:fillRef idx="3">
+            <a:schemeClr val="accent1"/>
+          </a:fillRef>
+          <a:effectRef idx="2">
+            <a:schemeClr val="accent1"/>
+          </a:effectRef>
+          <a:fontRef idx="minor">
+            <a:schemeClr val="lt1"/>
+          </a:fontRef>
+        </p:style>
+        <p:txBody>
+          <a:bodyPr rtlCol="0" anchor="ctr"/>
+          <a:lstStyle/>
+          <a:p>
+            <a:pPr algn="ctr"/>
+          </a:p>
+        </p:txBody>
+      </p:sp>
+      <p:sp>
+        <p:nvSpPr>
+          <p:cNvPr id="3" name="Rectangle 2"/>
+          <p:cNvSpPr/>
+          <p:nvPr/>
+        </p:nvSpPr>
+        <p:spPr>
+          <a:xfrm>
+            <a:off x="5029200" y="914400"/>
+            <a:ext cx="2743200" cy="1828800"/>
+          </a:xfrm>
+          <a:prstGeom prst="rect">
+            <a:avLst/>
+          </a:prstGeom>
+          <a:solidFill>
+            <a:srgbClr val="FFFFFF"/>
+          </a:solidFill>
+          <a:ln>
+            <a:noFill/>
+          </a:ln>
+          <a:effectLst/>
+        </p:spPr>
+        <p:style>
+          <a:lnRef idx="1">
+            <a:schemeClr val="accent1"/>
+          </a:lnRef>
+          <a:fillRef idx="3">
+            <a:schemeClr val="accent1"/>
+          </a:fillRef>
+          <a:effectRef idx="2">
+            <a:schemeClr val="accent1"/>
+          </a:effectRef>
+          <a:fontRef idx="minor">
+            <a:schemeClr val="lt1"/>
+          </a:fontRef>
+        </p:style>
+        <p:txBody>
+          <a:bodyPr rtlCol="0" anchor="ctr"/>
+          <a:lstStyle/>
+          <a:p>
+            <a:pPr algn="ctr"/>
+          </a:p>
+        </p:txBody>
+      </p:sp>
+      <p:sp>
+        <p:nvSpPr>
+          <p:cNvPr id="4" name="TextBox 3"/>
+          <p:cNvSpPr txBox="1"/>
+          <p:nvPr/>
+        </p:nvSpPr>
+        <p:spPr>
+          <a:xfrm>
+            <a:off x="914400" y="4114800"/>
+            <a:ext cx="7315200" cy="914400"/>
+          </a:xfrm>
+          <a:prstGeom prst="rect">
+            <a:avLst/>
+          </a:prstGeom>
+          <a:noFill/>
+        </p:spPr>
+        <p:txBody>
+          <a:bodyPr wrap="none">
+            <a:spAutoFit/>
+          </a:bodyPr>
+          <a:lstStyle/>
+          <a:p>
+            <a:r>
+              <a:rPr sz="4000">
+                <a:solidFill>
+                  <a:srgbClr val="FFFFFF"/>
+                </a:solidFill>
+                <a:highlight>
+                  <a:srgbClr val="FFC000"/>
+                </a:highlight>
+              </a:rPr>
+              <a:t>highlighted</a:t>
+            </a:r>
+          </a:p>
+        </p:txBody>
+      </p:sp>
+    </p:spTree>
+  </p:cSld>
+  <p:clrMapOvr>
+    <a:masterClrMapping/>
+  </p:clrMapOvr>
+</p:sld>
+</file>
+
+<file path=ppt/slides/slide9.xml><?xml version="1.0" encoding="utf-8"?>
 <p:sld xmlns:a="http://schemas.openxmlformats.org/drawingml/2006/main" xmlns:p="http://schemas.openxmlformats.org/presentationml/2006/main" xmlns:r="http://schemas.openxmlformats.org/officeDocument/2006/relationships" show="0">
   <p:cSld>
     <p:spTree>

</xml_diff>

<commit_message>
Leave PPTX tables without a style id unstyled; grow rows to fit their text
A table with no <a:tableStyleId> was given PowerPoint's default style, the
one tableStyles.xml's "def" names for tables inserted later; it has none.
On a dark slide that put white text on light cells. Row heights are
minimums: PowerPoint grows a row to fit its cells' text, and a frame saved
shorter than its rows no longer squeezes them. On 34 real decks the mean
difference from LibreOffice goes from 2.17 to 1.96.
</commit_message>
<xml_diff>
--- a/officecanvas/src/test/resources/pptx_samples/pptx_features.pptx
+++ b/officecanvas/src/test/resources/pptx_samples/pptx_features.pptx
@@ -3886,6 +3886,87 @@
                     <a:p>
                       <a:r>
                         <a:t>r2c1</a:t>
+                      </a:r>
+                    </a:p>
+                  </a:txBody>
+                  <a:tcPr/>
+                </a:tc>
+              </a:tr>
+            </a:tbl>
+          </a:graphicData>
+        </a:graphic>
+      </p:graphicFrame>
+      <p:graphicFrame>
+        <p:nvGraphicFramePr>
+          <p:cNvPr id="3" name="Table 2"/>
+          <p:cNvGraphicFramePr>
+            <a:graphicFrameLocks noGrp="1"/>
+          </p:cNvGraphicFramePr>
+          <p:nvPr/>
+        </p:nvGraphicFramePr>
+        <p:xfrm>
+          <a:off x="914400" y="4114800"/>
+          <a:ext cx="3657600" cy="182880"/>
+        </p:xfrm>
+        <a:graphic>
+          <a:graphicData uri="http://schemas.openxmlformats.org/drawingml/2006/table">
+            <a:tbl>
+              <a:tblPr/>
+              <a:tblGrid>
+                <a:gridCol w="3657600"/>
+              </a:tblGrid>
+              <a:tr h="91440">
+                <a:tc>
+                  <a:txBody>
+                    <a:bodyPr/>
+                    <a:lstStyle/>
+                    <a:p>
+                      <a:r>
+                        <a:rPr sz="1800">
+                          <a:solidFill>
+                            <a:srgbClr val="000000"/>
+                          </a:solidFill>
+                        </a:rPr>
+                        <a:t>one</a:t>
+                      </a:r>
+                    </a:p>
+                    <a:p>
+                      <a:r>
+                        <a:rPr sz="1800">
+                          <a:solidFill>
+                            <a:srgbClr val="000000"/>
+                          </a:solidFill>
+                        </a:rPr>
+                        <a:t>two</a:t>
+                      </a:r>
+                    </a:p>
+                    <a:p>
+                      <a:r>
+                        <a:rPr sz="1800">
+                          <a:solidFill>
+                            <a:srgbClr val="000000"/>
+                          </a:solidFill>
+                        </a:rPr>
+                        <a:t>three</a:t>
+                      </a:r>
+                    </a:p>
+                  </a:txBody>
+                  <a:tcPr/>
+                </a:tc>
+              </a:tr>
+              <a:tr h="91440">
+                <a:tc>
+                  <a:txBody>
+                    <a:bodyPr/>
+                    <a:lstStyle/>
+                    <a:p>
+                      <a:r>
+                        <a:rPr sz="1800">
+                          <a:solidFill>
+                            <a:srgbClr val="000000"/>
+                          </a:solidFill>
+                        </a:rPr>
+                        <a:t>below</a:t>
                       </a:r>
                     </a:p>
                   </a:txBody>

</xml_diff>

<commit_message>
Start PPTX numbering over after a bulleted paragraph
A bulleted paragraph between numbered ones at the same level ends the
sequence, as an unnumbered one does; the numbers after it went on from
before it.
</commit_message>
<xml_diff>
--- a/officecanvas/src/test/resources/pptx_samples/pptx_features.pptx
+++ b/officecanvas/src/test/resources/pptx_samples/pptx_features.pptx
@@ -3551,6 +3551,22 @@
             </a:pPr>
             <a:r>
               <a:t>Gamma</a:t>
+            </a:r>
+          </a:p>
+          <a:p>
+            <a:pPr marL="342900" indent="-342900">
+              <a:buChar char="•"/>
+            </a:pPr>
+            <a:r>
+              <a:t>Note</a:t>
+            </a:r>
+          </a:p>
+          <a:p>
+            <a:pPr marL="342900" indent="-342900">
+              <a:buAutoNum type="arabicPeriod"/>
+            </a:pPr>
+            <a:r>
+              <a:t>Delta</a:t>
             </a:r>
           </a:p>
         </p:txBody>

</xml_diff>

<commit_message>
Draw PPTX shapes and pictures turned in 3-D, with their extrusion
A shape's camera rotation (<a:scene3d><a:camera><a:rot lat lon rev>) turns
it out of the slide's plane: its box's corners are rotated and projected
(with perspective for perspective cameras) and the shape, its text or the
picture drawn through that mapping. An extrusion (<a:sp3d extrusionH>) is
the silhouette swept back to its depth in the extrusion color first. On the
one deck using these, the difference from LibreOffice goes from 4.2 to 3.5.

The sample deck gains a turned and flipped group with a grpFill member and
an extruded 3-D box, tested here for both changes.
</commit_message>
<xml_diff>
--- a/officecanvas/src/test/resources/pptx_samples/pptx_features.pptx
+++ b/officecanvas/src/test/resources/pptx_samples/pptx_features.pptx
@@ -4136,6 +4136,159 @@
               </a:rPr>
               <a:t>highlighted</a:t>
             </a:r>
+          </a:p>
+        </p:txBody>
+      </p:sp>
+      <p:grpSp>
+        <p:nvGrpSpPr>
+          <p:cNvPr id="5" name="Group 4"/>
+          <p:cNvGrpSpPr/>
+          <p:nvPr/>
+        </p:nvGrpSpPr>
+        <p:grpSpPr>
+          <a:xfrm rot="5400000" flipH="1">
+            <a:off x="5486400" y="4114800"/>
+            <a:ext cx="1371600" cy="914400"/>
+            <a:chOff x="5486400" y="4114800"/>
+            <a:chExt cx="1371600" cy="914400"/>
+          </a:xfrm>
+          <a:solidFill>
+            <a:srgbClr val="C00000"/>
+          </a:solidFill>
+        </p:grpSpPr>
+        <p:sp>
+          <p:nvSpPr>
+            <p:cNvPr id="6" name="Rectangle 5"/>
+            <p:cNvSpPr/>
+            <p:nvPr/>
+          </p:nvSpPr>
+          <p:spPr>
+            <a:xfrm>
+              <a:off x="5486400" y="4114800"/>
+              <a:ext cx="914400" cy="457200"/>
+            </a:xfrm>
+            <a:prstGeom prst="rect">
+              <a:avLst/>
+            </a:prstGeom>
+            <a:grpFill/>
+            <a:ln>
+              <a:noFill/>
+            </a:ln>
+          </p:spPr>
+          <p:style>
+            <a:lnRef idx="1">
+              <a:schemeClr val="accent1"/>
+            </a:lnRef>
+            <a:fillRef idx="3">
+              <a:schemeClr val="accent1"/>
+            </a:fillRef>
+            <a:effectRef idx="2">
+              <a:schemeClr val="accent1"/>
+            </a:effectRef>
+            <a:fontRef idx="minor">
+              <a:schemeClr val="lt1"/>
+            </a:fontRef>
+          </p:style>
+          <p:txBody>
+            <a:bodyPr rtlCol="0" anchor="ctr"/>
+            <a:lstStyle/>
+            <a:p>
+              <a:pPr algn="ctr"/>
+            </a:p>
+          </p:txBody>
+        </p:sp>
+        <p:sp>
+          <p:nvSpPr>
+            <p:cNvPr id="7" name="Oval 6"/>
+            <p:cNvSpPr/>
+            <p:nvPr/>
+          </p:nvSpPr>
+          <p:spPr>
+            <a:xfrm>
+              <a:off x="6400800" y="4572000"/>
+              <a:ext cx="457200" cy="457200"/>
+            </a:xfrm>
+            <a:prstGeom prst="ellipse">
+              <a:avLst/>
+            </a:prstGeom>
+            <a:ln>
+              <a:noFill/>
+            </a:ln>
+          </p:spPr>
+          <p:style>
+            <a:lnRef idx="1">
+              <a:schemeClr val="accent1"/>
+            </a:lnRef>
+            <a:fillRef idx="3">
+              <a:schemeClr val="accent1"/>
+            </a:fillRef>
+            <a:effectRef idx="2">
+              <a:schemeClr val="accent1"/>
+            </a:effectRef>
+            <a:fontRef idx="minor">
+              <a:schemeClr val="lt1"/>
+            </a:fontRef>
+          </p:style>
+          <p:txBody>
+            <a:bodyPr rtlCol="0" anchor="ctr"/>
+            <a:lstStyle/>
+            <a:p>
+              <a:pPr algn="ctr"/>
+            </a:p>
+          </p:txBody>
+        </p:sp>
+      </p:grpSp>
+      <p:sp>
+        <p:nvSpPr>
+          <p:cNvPr id="8" name="Rectangle 7"/>
+          <p:cNvSpPr/>
+          <p:nvPr/>
+        </p:nvSpPr>
+        <p:spPr>
+          <a:xfrm>
+            <a:off x="7680960" y="4023360"/>
+            <a:ext cx="1097280" cy="1097280"/>
+          </a:xfrm>
+          <a:prstGeom prst="rect">
+            <a:avLst/>
+          </a:prstGeom>
+          <a:solidFill>
+            <a:srgbClr val="FFFFFF"/>
+          </a:solidFill>
+          <a:ln>
+            <a:noFill/>
+          </a:ln>
+          <a:scene3d>
+            <a:camera prst="orthographicFront">
+              <a:rot lat="0" lon="3600000" rev="0"/>
+            </a:camera>
+            <a:lightRig rig="threePt" dir="t"/>
+          </a:scene3d>
+          <a:sp3d extrusionH="548640">
+            <a:extrusionClr>
+              <a:srgbClr val="0000C0"/>
+            </a:extrusionClr>
+          </a:sp3d>
+        </p:spPr>
+        <p:style>
+          <a:lnRef idx="1">
+            <a:schemeClr val="accent1"/>
+          </a:lnRef>
+          <a:fillRef idx="3">
+            <a:schemeClr val="accent1"/>
+          </a:fillRef>
+          <a:effectRef idx="2">
+            <a:schemeClr val="accent1"/>
+          </a:effectRef>
+          <a:fontRef idx="minor">
+            <a:schemeClr val="lt1"/>
+          </a:fontRef>
+        </p:style>
+        <p:txBody>
+          <a:bodyPr rtlCol="0" anchor="ctr"/>
+          <a:lstStyle/>
+          <a:p>
+            <a:pPr algn="ctr"/>
           </a:p>
         </p:txBody>
       </p:sp>

</xml_diff>

<commit_message>
Draw .pptx text shadows
An <a:outerShdw> in a run's own effect list was ignored; the letters now
get it as a shape does: offset by its distance and direction, blurred by
its radius, in its color.
</commit_message>
<xml_diff>
--- a/officecanvas/src/test/resources/pptx_samples/pptx_features.pptx
+++ b/officecanvas/src/test/resources/pptx_samples/pptx_features.pptx
@@ -4135,6 +4135,19 @@
                 </a:highlight>
               </a:rPr>
               <a:t>highlighted</a:t>
+            </a:r>
+            <a:r>
+              <a:rPr sz="4000">
+                <a:solidFill>
+                  <a:srgbClr val="FFFFFF"/>
+                </a:solidFill>
+                <a:effectLst>
+                  <a:outerShdw blurRad="0" dist="50800" dir="2700000" rotWithShape="0">
+                    <a:srgbClr val="000000"/>
+                  </a:outerShdw>
+                </a:effectLst>
+              </a:rPr>
+              <a:t> shadowed</a:t>
             </a:r>
           </a:p>
         </p:txBody>

</xml_diff>